<commit_message>
update VM link, show image digest in docker slides (#84)
</commit_message>
<xml_diff>
--- a/docker/03_Image_Lifecycle.pptx
+++ b/docker/03_Image_Lifecycle.pptx
@@ -29834,8 +29834,8 @@
         </p:nvSpPr>
         <p:spPr>
           <a:xfrm>
-            <a:off x="504001" y="2407566"/>
-            <a:ext cx="8667708" cy="2042867"/>
+            <a:off x="504001" y="2130567"/>
+            <a:ext cx="8667708" cy="2596865"/>
           </a:xfrm>
           <a:prstGeom prst="rect">
             <a:avLst/>
@@ -30123,6 +30123,92 @@
                 <a:cs typeface="Courier New" panose="02070309020205020404" pitchFamily="49" charset="0"/>
               </a:rPr>
               <a:t>nginx:latest</a:t>
+            </a:r>
+            <a:endParaRPr lang="de-DE" sz="1800" kern="0" dirty="0">
+              <a:latin typeface="Courier New" panose="02070309020205020404" pitchFamily="49" charset="0"/>
+              <a:ea typeface="Arial Unicode MS" pitchFamily="34" charset="-128"/>
+              <a:cs typeface="Courier New" panose="02070309020205020404" pitchFamily="49" charset="0"/>
+            </a:endParaRPr>
+          </a:p>
+          <a:p>
+            <a:pPr fontAlgn="base">
+              <a:lnSpc>
+                <a:spcPct val="150000"/>
+              </a:lnSpc>
+              <a:spcBef>
+                <a:spcPct val="50000"/>
+              </a:spcBef>
+              <a:spcAft>
+                <a:spcPct val="0"/>
+              </a:spcAft>
+              <a:buClr>
+                <a:srgbClr val="F0AB00"/>
+              </a:buClr>
+              <a:buSzPct val="80000"/>
+            </a:pPr>
+            <a:r>
+              <a:rPr lang="de-DE" sz="1800" kern="0" dirty="0">
+                <a:latin typeface="Courier New" panose="02070309020205020404" pitchFamily="49" charset="0"/>
+                <a:ea typeface="Arial Unicode MS" pitchFamily="34" charset="-128"/>
+                <a:cs typeface="Courier New" panose="02070309020205020404" pitchFamily="49" charset="0"/>
+              </a:rPr>
+              <a:t>$: </a:t>
+            </a:r>
+            <a:r>
+              <a:rPr lang="de-DE" sz="1800" kern="0" dirty="0" err="1">
+                <a:latin typeface="Courier New" panose="02070309020205020404" pitchFamily="49" charset="0"/>
+                <a:ea typeface="Arial Unicode MS" pitchFamily="34" charset="-128"/>
+                <a:cs typeface="Courier New" panose="02070309020205020404" pitchFamily="49" charset="0"/>
+              </a:rPr>
+              <a:t>docker</a:t>
+            </a:r>
+            <a:r>
+              <a:rPr lang="de-DE" sz="1800" kern="0" dirty="0">
+                <a:latin typeface="Courier New" panose="02070309020205020404" pitchFamily="49" charset="0"/>
+                <a:ea typeface="Arial Unicode MS" pitchFamily="34" charset="-128"/>
+                <a:cs typeface="Courier New" panose="02070309020205020404" pitchFamily="49" charset="0"/>
+              </a:rPr>
+              <a:t> </a:t>
+            </a:r>
+            <a:r>
+              <a:rPr lang="de-DE" sz="1800" kern="0" dirty="0" err="1">
+                <a:latin typeface="Courier New" panose="02070309020205020404" pitchFamily="49" charset="0"/>
+                <a:ea typeface="Arial Unicode MS" pitchFamily="34" charset="-128"/>
+                <a:cs typeface="Courier New" panose="02070309020205020404" pitchFamily="49" charset="0"/>
+              </a:rPr>
+              <a:t>image</a:t>
+            </a:r>
+            <a:r>
+              <a:rPr lang="de-DE" sz="1800" kern="0" dirty="0">
+                <a:latin typeface="Courier New" panose="02070309020205020404" pitchFamily="49" charset="0"/>
+                <a:ea typeface="Arial Unicode MS" pitchFamily="34" charset="-128"/>
+                <a:cs typeface="Courier New" panose="02070309020205020404" pitchFamily="49" charset="0"/>
+              </a:rPr>
+              <a:t> </a:t>
+            </a:r>
+            <a:r>
+              <a:rPr lang="de-DE" sz="1800" kern="0" dirty="0" err="1">
+                <a:latin typeface="Courier New" panose="02070309020205020404" pitchFamily="49" charset="0"/>
+                <a:ea typeface="Arial Unicode MS" pitchFamily="34" charset="-128"/>
+                <a:cs typeface="Courier New" panose="02070309020205020404" pitchFamily="49" charset="0"/>
+              </a:rPr>
+              <a:t>list</a:t>
+            </a:r>
+            <a:r>
+              <a:rPr lang="de-DE" sz="1800" kern="0" dirty="0">
+                <a:latin typeface="Courier New" panose="02070309020205020404" pitchFamily="49" charset="0"/>
+                <a:ea typeface="Arial Unicode MS" pitchFamily="34" charset="-128"/>
+                <a:cs typeface="Courier New" panose="02070309020205020404" pitchFamily="49" charset="0"/>
+              </a:rPr>
+              <a:t> </a:t>
+            </a:r>
+            <a:r>
+              <a:rPr lang="de-DE" sz="1800" kern="0">
+                <a:latin typeface="Courier New" panose="02070309020205020404" pitchFamily="49" charset="0"/>
+                <a:ea typeface="Arial Unicode MS" pitchFamily="34" charset="-128"/>
+                <a:cs typeface="Courier New" panose="02070309020205020404" pitchFamily="49" charset="0"/>
+              </a:rPr>
+              <a:t>--digest</a:t>
             </a:r>
             <a:endParaRPr lang="de-DE" sz="1800" kern="0" dirty="0">
               <a:latin typeface="Courier New" panose="02070309020205020404" pitchFamily="49" charset="0"/>

</xml_diff>